<commit_message>
Fix stale repo name on closing slide (SpecimenCasebook -> specimen-casebook)
- slides/slide-08.png: patch the SOURCE URL to the real lowercase repo path.
- deck PPTX: same fix in the source deck.
- re-rendered demo MP4 so the closing frame shows the correct URL.

Co-Authored-By: Claude Fable 5 <noreply@anthropic.com>
</commit_message>
<xml_diff>
--- a/demo/SpecimenCasebook_Hackathon_Deck.pptx
+++ b/demo/SpecimenCasebook_Hackathon_Deck.pptx
@@ -8480,6 +8480,10 @@
             <a:prstDash val="solid"/>
           </a:ln>
         </p:spPr>
+        <p:txBody xmlns:a="http://schemas.openxmlformats.org/drawingml/2006/main">
+          <a:bodyPr/>
+          <a:p/>
+        </p:txBody>
       </p:sp>
       <p:sp>
         <p:nvSpPr>
@@ -8511,6 +8515,10 @@
             <a:prstDash val="solid"/>
           </a:ln>
         </p:spPr>
+        <p:txBody xmlns:a="http://schemas.openxmlformats.org/drawingml/2006/main">
+          <a:bodyPr/>
+          <a:p/>
+        </p:txBody>
       </p:sp>
       <p:sp>
         <p:nvSpPr>
@@ -8713,6 +8721,10 @@
             <a:prstDash val="solid"/>
           </a:ln>
         </p:spPr>
+        <p:txBody xmlns:a="http://schemas.openxmlformats.org/drawingml/2006/main">
+          <a:bodyPr/>
+          <a:p/>
+        </p:txBody>
       </p:sp>
       <p:sp>
         <p:nvSpPr>
@@ -8846,6 +8858,10 @@
             <a:prstDash val="solid"/>
           </a:ln>
         </p:spPr>
+        <p:txBody xmlns:a="http://schemas.openxmlformats.org/drawingml/2006/main">
+          <a:bodyPr/>
+          <a:p/>
+        </p:txBody>
       </p:sp>
       <p:sp>
         <p:nvSpPr>
@@ -8959,7 +8975,7 @@
                   <a:srgbClr val="17241D"/>
                 </a:solidFill>
               </a:rPr>
-              <a:t>SpecimenCasebook</a:t>
+              <a:t>specimen-casebook</a:t>
             </a:r>
           </a:p>
         </p:txBody>

</xml_diff>